<commit_message>
fixed grad update bugs
</commit_message>
<xml_diff>
--- a/DLL26 - NR9 Poster.pptx
+++ b/DLL26 - NR9 Poster.pptx
@@ -3105,7 +3105,7 @@
               <a:buChar char="•"/>
             </a:pPr>
             <a:r>
-              <a:rPr lang="en-US" sz="1300" dirty="0">
+              <a:rPr lang="en-US" sz="1600" dirty="0">
                 <a:solidFill>
                   <a:schemeClr val="dk1"/>
                 </a:solidFill>
@@ -3125,7 +3125,7 @@
               <a:buChar char="•"/>
             </a:pPr>
             <a:r>
-              <a:rPr lang="en-US" sz="1300" dirty="0">
+              <a:rPr lang="en-US" sz="1600" dirty="0">
                 <a:solidFill>
                   <a:schemeClr val="dk1"/>
                 </a:solidFill>
@@ -3145,7 +3145,7 @@
               <a:buChar char="•"/>
             </a:pPr>
             <a:r>
-              <a:rPr lang="en-US" sz="1300" dirty="0">
+              <a:rPr lang="en-US" sz="1600" dirty="0">
                 <a:solidFill>
                   <a:schemeClr val="dk1"/>
                 </a:solidFill>
@@ -3377,61 +3377,184 @@
           </a:bodyPr>
           <a:lstStyle/>
           <a:p>
-            <a:pPr marL="0" lvl="0" indent="0" algn="l" rtl="0">
+            <a:pPr lvl="0">
               <a:lnSpc>
                 <a:spcPct val="115000"/>
               </a:lnSpc>
-              <a:spcBef>
-                <a:spcPts val="0"/>
-              </a:spcBef>
-              <a:spcAft>
-                <a:spcPts val="0"/>
-              </a:spcAft>
-              <a:buNone/>
             </a:pPr>
             <a:r>
-              <a:rPr lang="en-US" sz="2200"/>
-              <a:t>[1] …</a:t>
-            </a:r>
-            <a:endParaRPr sz="2200"/>
+              <a:rPr lang="en-US" sz="2200" dirty="0"/>
+              <a:t>[1] </a:t>
+            </a:r>
+            <a:r>
+              <a:rPr lang="de-DE" sz="2200" dirty="0"/>
+              <a:t>Abdolmaleki, Abbas, et al. "Maximum a posteriori </a:t>
+            </a:r>
+            <a:r>
+              <a:rPr lang="de-DE" sz="2200" dirty="0" err="1"/>
+              <a:t>policy</a:t>
+            </a:r>
+            <a:r>
+              <a:rPr lang="de-DE" sz="2200" dirty="0"/>
+              <a:t> </a:t>
+            </a:r>
+            <a:r>
+              <a:rPr lang="de-DE" sz="2200" dirty="0" err="1"/>
+              <a:t>optimisation</a:t>
+            </a:r>
+            <a:r>
+              <a:rPr lang="de-DE" sz="2200" dirty="0"/>
+              <a:t>." </a:t>
+            </a:r>
+            <a:r>
+              <a:rPr lang="de-DE" sz="2200" i="1" dirty="0" err="1"/>
+              <a:t>arXiv</a:t>
+            </a:r>
+            <a:r>
+              <a:rPr lang="de-DE" sz="2200" i="1" dirty="0"/>
+              <a:t> </a:t>
+            </a:r>
+            <a:r>
+              <a:rPr lang="de-DE" sz="2200" i="1" dirty="0" err="1"/>
+              <a:t>preprint</a:t>
+            </a:r>
+            <a:r>
+              <a:rPr lang="de-DE" sz="2200" i="1" dirty="0"/>
+              <a:t> arXiv:1806.06920</a:t>
+            </a:r>
+            <a:r>
+              <a:rPr lang="de-DE" sz="2200" dirty="0"/>
+              <a:t> (2018).</a:t>
+            </a:r>
+            <a:endParaRPr sz="2200" dirty="0"/>
           </a:p>
           <a:p>
-            <a:pPr marL="0" lvl="0" indent="0" algn="l" rtl="0">
+            <a:pPr lvl="0">
               <a:lnSpc>
                 <a:spcPct val="115000"/>
               </a:lnSpc>
-              <a:spcBef>
-                <a:spcPts val="0"/>
-              </a:spcBef>
-              <a:spcAft>
-                <a:spcPts val="0"/>
-              </a:spcAft>
-              <a:buNone/>
             </a:pPr>
             <a:r>
-              <a:rPr lang="en-US" sz="2200"/>
-              <a:t>[2] …</a:t>
-            </a:r>
-            <a:endParaRPr sz="2200"/>
+              <a:rPr lang="en-US" sz="2200" dirty="0"/>
+              <a:t>[2] </a:t>
+            </a:r>
+            <a:r>
+              <a:rPr lang="de-DE" sz="2200" dirty="0" err="1"/>
+              <a:t>Tunyasuvunakool</a:t>
+            </a:r>
+            <a:r>
+              <a:rPr lang="de-DE" sz="2200" dirty="0"/>
+              <a:t>, Saran, et al. "</a:t>
+            </a:r>
+            <a:r>
+              <a:rPr lang="de-DE" sz="2200" dirty="0" err="1"/>
+              <a:t>dm_control</a:t>
+            </a:r>
+            <a:r>
+              <a:rPr lang="de-DE" sz="2200" dirty="0"/>
+              <a:t>: Software and </a:t>
+            </a:r>
+            <a:r>
+              <a:rPr lang="de-DE" sz="2200" dirty="0" err="1"/>
+              <a:t>tasks</a:t>
+            </a:r>
+            <a:r>
+              <a:rPr lang="de-DE" sz="2200" dirty="0"/>
+              <a:t> </a:t>
+            </a:r>
+            <a:r>
+              <a:rPr lang="de-DE" sz="2200" dirty="0" err="1"/>
+              <a:t>for</a:t>
+            </a:r>
+            <a:r>
+              <a:rPr lang="de-DE" sz="2200" dirty="0"/>
+              <a:t> </a:t>
+            </a:r>
+            <a:r>
+              <a:rPr lang="de-DE" sz="2200" dirty="0" err="1"/>
+              <a:t>continuous</a:t>
+            </a:r>
+            <a:r>
+              <a:rPr lang="de-DE" sz="2200" dirty="0"/>
+              <a:t> </a:t>
+            </a:r>
+            <a:r>
+              <a:rPr lang="de-DE" sz="2200" dirty="0" err="1"/>
+              <a:t>control</a:t>
+            </a:r>
+            <a:r>
+              <a:rPr lang="de-DE" sz="2200" dirty="0"/>
+              <a:t>." </a:t>
+            </a:r>
+            <a:r>
+              <a:rPr lang="de-DE" sz="2200" i="1" dirty="0"/>
+              <a:t>Software Impacts</a:t>
+            </a:r>
+            <a:r>
+              <a:rPr lang="de-DE" sz="2200" dirty="0"/>
+              <a:t> 6 (2020): 100022.</a:t>
+            </a:r>
+            <a:endParaRPr sz="2200" dirty="0"/>
           </a:p>
           <a:p>
-            <a:pPr marL="0" lvl="0" indent="0" algn="l" rtl="0">
+            <a:pPr lvl="0">
               <a:lnSpc>
                 <a:spcPct val="115000"/>
               </a:lnSpc>
-              <a:spcBef>
-                <a:spcPts val="0"/>
-              </a:spcBef>
-              <a:spcAft>
-                <a:spcPts val="0"/>
-              </a:spcAft>
-              <a:buNone/>
             </a:pPr>
             <a:r>
-              <a:rPr lang="en-US" sz="2200"/>
-              <a:t>[3] …</a:t>
-            </a:r>
-            <a:endParaRPr sz="2200"/>
+              <a:rPr lang="en-US" sz="2200" dirty="0"/>
+              <a:t>[3] </a:t>
+            </a:r>
+            <a:r>
+              <a:rPr lang="de-DE" sz="2200" dirty="0"/>
+              <a:t>Schulman, John, et al. "Proximal </a:t>
+            </a:r>
+            <a:r>
+              <a:rPr lang="de-DE" sz="2200" dirty="0" err="1"/>
+              <a:t>policy</a:t>
+            </a:r>
+            <a:r>
+              <a:rPr lang="de-DE" sz="2200" dirty="0"/>
+              <a:t> </a:t>
+            </a:r>
+            <a:r>
+              <a:rPr lang="de-DE" sz="2200" dirty="0" err="1"/>
+              <a:t>optimization</a:t>
+            </a:r>
+            <a:r>
+              <a:rPr lang="de-DE" sz="2200" dirty="0"/>
+              <a:t> </a:t>
+            </a:r>
+            <a:r>
+              <a:rPr lang="de-DE" sz="2200" dirty="0" err="1"/>
+              <a:t>algorithms</a:t>
+            </a:r>
+            <a:r>
+              <a:rPr lang="de-DE" sz="2200" dirty="0"/>
+              <a:t>." </a:t>
+            </a:r>
+            <a:r>
+              <a:rPr lang="de-DE" sz="2200" i="1" dirty="0" err="1"/>
+              <a:t>arXiv</a:t>
+            </a:r>
+            <a:r>
+              <a:rPr lang="de-DE" sz="2200" i="1" dirty="0"/>
+              <a:t> </a:t>
+            </a:r>
+            <a:r>
+              <a:rPr lang="de-DE" sz="2200" i="1" dirty="0" err="1"/>
+              <a:t>preprint</a:t>
+            </a:r>
+            <a:r>
+              <a:rPr lang="de-DE" sz="2200" i="1" dirty="0"/>
+              <a:t> arXiv:1707.06347</a:t>
+            </a:r>
+            <a:r>
+              <a:rPr lang="de-DE" sz="2200" dirty="0"/>
+              <a:t> (2017).</a:t>
+            </a:r>
+            <a:endParaRPr sz="2200" dirty="0"/>
           </a:p>
         </p:txBody>
       </p:sp>
@@ -3642,7 +3765,7 @@
               <a:buChar char="•"/>
             </a:pPr>
             <a:r>
-              <a:rPr lang="en-US" sz="1300" dirty="0">
+              <a:rPr lang="en-US" sz="1600" dirty="0">
                 <a:solidFill>
                   <a:schemeClr val="dk1"/>
                 </a:solidFill>
@@ -3662,7 +3785,7 @@
               <a:buChar char="•"/>
             </a:pPr>
             <a:r>
-              <a:rPr lang="en-US" sz="1300" dirty="0">
+              <a:rPr lang="en-US" sz="1600" dirty="0">
                 <a:solidFill>
                   <a:schemeClr val="dk1"/>
                 </a:solidFill>
@@ -3670,14 +3793,14 @@
               <a:t>Train on easy native tasks -&gt; cartpole balance/</a:t>
             </a:r>
             <a:r>
-              <a:rPr lang="en-US" sz="1300" dirty="0" err="1">
+              <a:rPr lang="en-US" sz="1600" dirty="0" err="1">
                 <a:solidFill>
                   <a:schemeClr val="dk1"/>
                 </a:solidFill>
               </a:rPr>
               <a:t>swingup</a:t>
             </a:r>
-            <a:endParaRPr lang="en-US" sz="1300" i="1" dirty="0">
+            <a:endParaRPr lang="en-US" sz="1600" i="1" dirty="0">
               <a:solidFill>
                 <a:schemeClr val="dk1"/>
               </a:solidFill>
@@ -3695,26 +3818,13 @@
               <a:buChar char="•"/>
             </a:pPr>
             <a:r>
-              <a:rPr lang="en-US" sz="1300" dirty="0">
+              <a:rPr lang="en-US" sz="1600" dirty="0">
                 <a:solidFill>
                   <a:schemeClr val="dk1"/>
                 </a:solidFill>
               </a:rPr>
-              <a:t>Implement incrementally more difficult environments (first cartpole with ball, then with joint, then standing agent, then walking agent, then </a:t>
-            </a:r>
-            <a:r>
-              <a:rPr lang="en-US" sz="1300">
-                <a:solidFill>
-                  <a:schemeClr val="dk1"/>
-                </a:solidFill>
-              </a:rPr>
-              <a:t>with ball)</a:t>
-            </a:r>
-            <a:endParaRPr lang="en-US" sz="1300" dirty="0">
-              <a:solidFill>
-                <a:schemeClr val="dk1"/>
-              </a:solidFill>
-            </a:endParaRPr>
+              <a:t>Implement incrementally more difficult environments (first cartpole with ball, then with joint, then standing agent, then walking agent, then with ball)</a:t>
+            </a:r>
           </a:p>
         </p:txBody>
       </p:sp>
@@ -3836,14 +3946,14 @@
               <a:buNone/>
             </a:pPr>
             <a:r>
-              <a:rPr lang="en-US" sz="3100" b="1">
+              <a:rPr lang="en-US" sz="3100" b="1" dirty="0">
                 <a:solidFill>
                   <a:schemeClr val="dk1"/>
                 </a:solidFill>
               </a:rPr>
               <a:t>Acknowledgement:</a:t>
             </a:r>
-            <a:endParaRPr sz="3100">
+            <a:endParaRPr sz="3100" dirty="0">
               <a:solidFill>
                 <a:schemeClr val="dk1"/>
               </a:solidFill>

</xml_diff>

<commit_message>
added method section to poster
</commit_message>
<xml_diff>
--- a/DLL26 - NR9 Poster.pptx
+++ b/DLL26 - NR9 Poster.pptx
@@ -3094,24 +3094,283 @@
           </a:bodyPr>
           <a:lstStyle/>
           <a:p>
-            <a:pPr marL="285750" lvl="0" indent="-285750" algn="l" rtl="0">
-              <a:spcBef>
-                <a:spcPts val="0"/>
-              </a:spcBef>
-              <a:spcAft>
-                <a:spcPts val="0"/>
-              </a:spcAft>
+            <a:pPr lvl="0" algn="l" rtl="0">
+              <a:spcBef>
+                <a:spcPts val="0"/>
+              </a:spcBef>
+              <a:spcAft>
+                <a:spcPts val="0"/>
+              </a:spcAft>
+            </a:pPr>
+            <a:r>
+              <a:rPr lang="en-US" sz="2400" b="1" dirty="0">
+                <a:solidFill>
+                  <a:schemeClr val="dk1"/>
+                </a:solidFill>
+              </a:rPr>
+              <a:t>TASK:</a:t>
+            </a:r>
+          </a:p>
+          <a:p>
+            <a:pPr marL="342900" lvl="0" indent="-342900">
               <a:buFont typeface="Arial" panose="020B0604020202020204" pitchFamily="34" charset="0"/>
               <a:buChar char="•"/>
             </a:pPr>
             <a:r>
-              <a:rPr lang="en-US" sz="1600" dirty="0">
+              <a:rPr lang="en-US" sz="2400" dirty="0">
                 <a:solidFill>
                   <a:schemeClr val="dk1"/>
                 </a:solidFill>
               </a:rPr>
-              <a:t>Task description</a:t>
-            </a:r>
+              <a:t>Implement DeepMind’s </a:t>
+            </a:r>
+            <a:r>
+              <a:rPr lang="de-DE" sz="2400" b="1" dirty="0"/>
+              <a:t>Maximum a Posteriori Policy </a:t>
+            </a:r>
+            <a:r>
+              <a:rPr lang="de-DE" sz="2400" b="1" dirty="0" err="1"/>
+              <a:t>Optimization</a:t>
+            </a:r>
+            <a:r>
+              <a:rPr lang="de-DE" sz="2400" dirty="0"/>
+              <a:t> (MPO)</a:t>
+            </a:r>
+            <a:r>
+              <a:rPr lang="en-US" sz="2400" dirty="0">
+                <a:solidFill>
+                  <a:schemeClr val="dk1"/>
+                </a:solidFill>
+              </a:rPr>
+              <a:t> algorithm from scratch</a:t>
+            </a:r>
+          </a:p>
+          <a:p>
+            <a:pPr marL="342900" lvl="0" indent="-342900" algn="l" rtl="0">
+              <a:spcBef>
+                <a:spcPts val="0"/>
+              </a:spcBef>
+              <a:spcAft>
+                <a:spcPts val="0"/>
+              </a:spcAft>
+              <a:buFont typeface="Arial" panose="020B0604020202020204" pitchFamily="34" charset="0"/>
+              <a:buChar char="•"/>
+            </a:pPr>
+            <a:r>
+              <a:rPr lang="en-US" sz="2400" dirty="0">
+                <a:solidFill>
+                  <a:schemeClr val="dk1"/>
+                </a:solidFill>
+              </a:rPr>
+              <a:t>Investigate MPO’s training dynamics on simple continuous environments</a:t>
+            </a:r>
+          </a:p>
+          <a:p>
+            <a:pPr marL="342900" lvl="0" indent="-342900" algn="l" rtl="0">
+              <a:spcBef>
+                <a:spcPts val="0"/>
+              </a:spcBef>
+              <a:spcAft>
+                <a:spcPts val="0"/>
+              </a:spcAft>
+              <a:buFont typeface="Arial" panose="020B0604020202020204" pitchFamily="34" charset="0"/>
+              <a:buChar char="•"/>
+            </a:pPr>
+            <a:r>
+              <a:rPr lang="en-US" sz="2400" dirty="0">
+                <a:solidFill>
+                  <a:schemeClr val="dk1"/>
+                </a:solidFill>
+              </a:rPr>
+              <a:t>Using MPO, train an agent to score a goal in a custom </a:t>
+            </a:r>
+            <a:r>
+              <a:rPr lang="en-US" sz="2400" dirty="0" err="1">
+                <a:solidFill>
+                  <a:schemeClr val="dk1"/>
+                </a:solidFill>
+              </a:rPr>
+              <a:t>dm_control’s</a:t>
+            </a:r>
+            <a:r>
+              <a:rPr lang="en-US" sz="2400" dirty="0">
+                <a:solidFill>
+                  <a:schemeClr val="dk1"/>
+                </a:solidFill>
+              </a:rPr>
+              <a:t> soccer environment</a:t>
+            </a:r>
+          </a:p>
+          <a:p>
+            <a:pPr marL="342900" lvl="0" indent="-342900" algn="l" rtl="0">
+              <a:spcBef>
+                <a:spcPts val="0"/>
+              </a:spcBef>
+              <a:spcAft>
+                <a:spcPts val="0"/>
+              </a:spcAft>
+              <a:buFont typeface="Arial" panose="020B0604020202020204" pitchFamily="34" charset="0"/>
+              <a:buChar char="•"/>
+            </a:pPr>
+            <a:endParaRPr lang="en-US" sz="2400" dirty="0">
+              <a:solidFill>
+                <a:schemeClr val="dk1"/>
+              </a:solidFill>
+            </a:endParaRPr>
+          </a:p>
+          <a:p>
+            <a:pPr marL="342900" lvl="0" indent="-342900" algn="l" rtl="0">
+              <a:spcBef>
+                <a:spcPts val="0"/>
+              </a:spcBef>
+              <a:spcAft>
+                <a:spcPts val="0"/>
+              </a:spcAft>
+              <a:buFont typeface="Arial" panose="020B0604020202020204" pitchFamily="34" charset="0"/>
+              <a:buChar char="•"/>
+            </a:pPr>
+            <a:endParaRPr lang="en-US" sz="2400" dirty="0">
+              <a:solidFill>
+                <a:schemeClr val="dk1"/>
+              </a:solidFill>
+            </a:endParaRPr>
+          </a:p>
+          <a:p>
+            <a:pPr lvl="0" algn="l" rtl="0">
+              <a:spcBef>
+                <a:spcPts val="0"/>
+              </a:spcBef>
+              <a:spcAft>
+                <a:spcPts val="0"/>
+              </a:spcAft>
+            </a:pPr>
+            <a:r>
+              <a:rPr lang="en-US" sz="2400" b="1" dirty="0">
+                <a:solidFill>
+                  <a:schemeClr val="dk1"/>
+                </a:solidFill>
+              </a:rPr>
+              <a:t>CHALLENGES:</a:t>
+            </a:r>
+          </a:p>
+          <a:p>
+            <a:pPr marL="342900" lvl="0" indent="-342900" algn="l" rtl="0">
+              <a:spcBef>
+                <a:spcPts val="0"/>
+              </a:spcBef>
+              <a:spcAft>
+                <a:spcPts val="0"/>
+              </a:spcAft>
+              <a:buFont typeface="Arial" panose="020B0604020202020204" pitchFamily="34" charset="0"/>
+              <a:buChar char="•"/>
+            </a:pPr>
+            <a:r>
+              <a:rPr lang="en-US" sz="2400" dirty="0">
+                <a:solidFill>
+                  <a:schemeClr val="dk1"/>
+                </a:solidFill>
+              </a:rPr>
+              <a:t>Continuous control with high degree of freedom</a:t>
+            </a:r>
+          </a:p>
+          <a:p>
+            <a:pPr marL="342900" lvl="0" indent="-342900">
+              <a:buFont typeface="Arial" panose="020B0604020202020204" pitchFamily="34" charset="0"/>
+              <a:buChar char="•"/>
+            </a:pPr>
+            <a:r>
+              <a:rPr lang="de-DE" sz="2400" dirty="0"/>
+              <a:t>Learning </a:t>
+            </a:r>
+            <a:r>
+              <a:rPr lang="de-DE" sz="2400" dirty="0" err="1"/>
+              <a:t>stable</a:t>
+            </a:r>
+            <a:r>
+              <a:rPr lang="de-DE" sz="2400" dirty="0"/>
+              <a:t> </a:t>
+            </a:r>
+            <a:r>
+              <a:rPr lang="de-DE" sz="2400" dirty="0" err="1"/>
+              <a:t>bipedal</a:t>
+            </a:r>
+            <a:r>
+              <a:rPr lang="de-DE" sz="2400" dirty="0"/>
+              <a:t> </a:t>
+            </a:r>
+            <a:r>
+              <a:rPr lang="de-DE" sz="2400" dirty="0" err="1"/>
+              <a:t>locomotion</a:t>
+            </a:r>
+            <a:r>
+              <a:rPr lang="de-DE" sz="2400" dirty="0"/>
+              <a:t> (i.e. „</a:t>
+            </a:r>
+            <a:r>
+              <a:rPr lang="de-DE" sz="2400" dirty="0" err="1"/>
+              <a:t>standing</a:t>
+            </a:r>
+            <a:r>
+              <a:rPr lang="de-DE" sz="2400" dirty="0"/>
+              <a:t>“) </a:t>
+            </a:r>
+            <a:r>
+              <a:rPr lang="en-US" sz="2400" dirty="0">
+                <a:solidFill>
+                  <a:schemeClr val="dk1"/>
+                </a:solidFill>
+              </a:rPr>
+              <a:t>difficult to learn in and of itself</a:t>
+            </a:r>
+          </a:p>
+          <a:p>
+            <a:pPr marL="342900" lvl="0" indent="-342900" algn="l" rtl="0">
+              <a:spcBef>
+                <a:spcPts val="0"/>
+              </a:spcBef>
+              <a:spcAft>
+                <a:spcPts val="0"/>
+              </a:spcAft>
+              <a:buFont typeface="Arial" panose="020B0604020202020204" pitchFamily="34" charset="0"/>
+              <a:buChar char="•"/>
+            </a:pPr>
+            <a:r>
+              <a:rPr lang="en-US" sz="2400" dirty="0">
+                <a:solidFill>
+                  <a:schemeClr val="dk1"/>
+                </a:solidFill>
+              </a:rPr>
+              <a:t>Kicking the ball requires policy to learn sequence of skills:	standing </a:t>
+            </a:r>
+            <a:r>
+              <a:rPr lang="en-US" sz="2400" dirty="0">
+                <a:solidFill>
+                  <a:schemeClr val="dk1"/>
+                </a:solidFill>
+                <a:sym typeface="Wingdings" panose="05000000000000000000" pitchFamily="2" charset="2"/>
+              </a:rPr>
+              <a:t> walking  making controlled contact with ball  kick ball into goal</a:t>
+            </a:r>
+            <a:endParaRPr lang="en-US" sz="2400" dirty="0">
+              <a:solidFill>
+                <a:schemeClr val="dk1"/>
+              </a:solidFill>
+            </a:endParaRPr>
+          </a:p>
+          <a:p>
+            <a:pPr lvl="0" algn="l" rtl="0">
+              <a:spcBef>
+                <a:spcPts val="0"/>
+              </a:spcBef>
+              <a:spcAft>
+                <a:spcPts val="0"/>
+              </a:spcAft>
+            </a:pPr>
+            <a:endParaRPr lang="en-US" sz="2400" dirty="0">
+              <a:solidFill>
+                <a:schemeClr val="dk1"/>
+              </a:solidFill>
+            </a:endParaRPr>
           </a:p>
           <a:p>
             <a:pPr marL="285750" lvl="0" indent="-285750" algn="l" rtl="0">
@@ -3124,8 +3383,43 @@
               <a:buFont typeface="Arial" panose="020B0604020202020204" pitchFamily="34" charset="0"/>
               <a:buChar char="•"/>
             </a:pPr>
-            <a:r>
-              <a:rPr lang="en-US" sz="1600" dirty="0">
+            <a:endParaRPr lang="en-US" sz="2400" dirty="0">
+              <a:solidFill>
+                <a:schemeClr val="dk1"/>
+              </a:solidFill>
+            </a:endParaRPr>
+          </a:p>
+          <a:p>
+            <a:pPr lvl="0" algn="l" rtl="0">
+              <a:spcBef>
+                <a:spcPts val="0"/>
+              </a:spcBef>
+              <a:spcAft>
+                <a:spcPts val="0"/>
+              </a:spcAft>
+            </a:pPr>
+            <a:r>
+              <a:rPr lang="en-US" sz="2400" b="1" dirty="0">
+                <a:solidFill>
+                  <a:schemeClr val="dk1"/>
+                </a:solidFill>
+              </a:rPr>
+              <a:t>MPO ALGORITHM:</a:t>
+            </a:r>
+          </a:p>
+          <a:p>
+            <a:pPr marL="342900" lvl="0" indent="-342900" algn="l" rtl="0">
+              <a:spcBef>
+                <a:spcPts val="0"/>
+              </a:spcBef>
+              <a:spcAft>
+                <a:spcPts val="0"/>
+              </a:spcAft>
+              <a:buFont typeface="Arial" panose="020B0604020202020204" pitchFamily="34" charset="0"/>
+              <a:buChar char="•"/>
+            </a:pPr>
+            <a:r>
+              <a:rPr lang="en-US" sz="2400" dirty="0">
                 <a:solidFill>
                   <a:schemeClr val="dk1"/>
                 </a:solidFill>
@@ -3145,7 +3439,7 @@
               <a:buChar char="•"/>
             </a:pPr>
             <a:r>
-              <a:rPr lang="en-US" sz="1600" dirty="0">
+              <a:rPr lang="en-US" sz="2400" dirty="0">
                 <a:solidFill>
                   <a:schemeClr val="dk1"/>
                 </a:solidFill>
@@ -3162,7 +3456,7 @@
                 <a:spcPts val="0"/>
               </a:spcAft>
             </a:pPr>
-            <a:endParaRPr sz="1300" dirty="0">
+            <a:endParaRPr sz="2400" dirty="0">
               <a:solidFill>
                 <a:schemeClr val="dk1"/>
               </a:solidFill>
@@ -3754,77 +4048,811 @@
           </a:bodyPr>
           <a:lstStyle/>
           <a:p>
-            <a:pPr marL="285750" lvl="0" indent="-285750" algn="l" rtl="0">
-              <a:spcBef>
-                <a:spcPts val="0"/>
-              </a:spcBef>
-              <a:spcAft>
-                <a:spcPts val="0"/>
-              </a:spcAft>
-              <a:buFont typeface="Arial" panose="020B0604020202020204" pitchFamily="34" charset="0"/>
-              <a:buChar char="•"/>
+            <a:pPr marL="457200" lvl="0" indent="-457200">
+              <a:buFont typeface="+mj-lt"/>
+              <a:buAutoNum type="arabicPeriod"/>
             </a:pPr>
             <a:r>
-              <a:rPr lang="en-US" sz="1600" dirty="0">
+              <a:rPr lang="en-US" sz="2400" b="1" dirty="0">
                 <a:solidFill>
                   <a:schemeClr val="dk1"/>
                 </a:solidFill>
               </a:rPr>
-              <a:t>Implement MPO</a:t>
-            </a:r>
-          </a:p>
-          <a:p>
-            <a:pPr marL="285750" lvl="0" indent="-285750" algn="l" rtl="0">
-              <a:spcBef>
-                <a:spcPts val="0"/>
-              </a:spcBef>
-              <a:spcAft>
-                <a:spcPts val="0"/>
-              </a:spcAft>
-              <a:buFont typeface="Arial" panose="020B0604020202020204" pitchFamily="34" charset="0"/>
-              <a:buChar char="•"/>
-            </a:pPr>
-            <a:r>
-              <a:rPr lang="en-US" sz="1600" dirty="0">
+              <a:t>Implementation of MPO</a:t>
+            </a:r>
+            <a:br>
+              <a:rPr lang="en-US" sz="2400" b="1" dirty="0">
                 <a:solidFill>
                   <a:schemeClr val="dk1"/>
                 </a:solidFill>
               </a:rPr>
-              <a:t>Train on easy native tasks -&gt; cartpole balance/</a:t>
-            </a:r>
-            <a:r>
-              <a:rPr lang="en-US" sz="1600" dirty="0" err="1">
+            </a:br>
+            <a:r>
+              <a:rPr lang="en-US" sz="2400" b="1" dirty="0">
                 <a:solidFill>
                   <a:schemeClr val="dk1"/>
                 </a:solidFill>
               </a:rPr>
+              <a:t>- </a:t>
+            </a:r>
+            <a:r>
+              <a:rPr lang="de-DE" sz="2400" dirty="0"/>
+              <a:t>Implement </a:t>
+            </a:r>
+            <a:r>
+              <a:rPr lang="de-DE" sz="2400" dirty="0" err="1"/>
+              <a:t>the</a:t>
+            </a:r>
+            <a:r>
+              <a:rPr lang="de-DE" sz="2400" dirty="0"/>
+              <a:t> Maximum a Posteriori Policy </a:t>
+            </a:r>
+            <a:r>
+              <a:rPr lang="de-DE" sz="2400" dirty="0" err="1"/>
+              <a:t>Optimization</a:t>
+            </a:r>
+            <a:r>
+              <a:rPr lang="de-DE" sz="2400" dirty="0"/>
+              <a:t> </a:t>
+            </a:r>
+            <a:r>
+              <a:rPr lang="de-DE" sz="2400" dirty="0" err="1"/>
+              <a:t>algorithm</a:t>
+            </a:r>
+            <a:r>
+              <a:rPr lang="de-DE" sz="2400" dirty="0"/>
+              <a:t> </a:t>
+            </a:r>
+            <a:r>
+              <a:rPr lang="de-DE" sz="2400" dirty="0" err="1"/>
+              <a:t>according</a:t>
+            </a:r>
+            <a:r>
+              <a:rPr lang="de-DE" sz="2400" dirty="0"/>
+              <a:t> </a:t>
+            </a:r>
+            <a:r>
+              <a:rPr lang="de-DE" sz="2400" dirty="0" err="1"/>
+              <a:t>to</a:t>
+            </a:r>
+            <a:r>
+              <a:rPr lang="de-DE" sz="2400" dirty="0"/>
+              <a:t> </a:t>
+            </a:r>
+            <a:r>
+              <a:rPr lang="de-DE" sz="2400" dirty="0" err="1"/>
+              <a:t>the</a:t>
+            </a:r>
+            <a:r>
+              <a:rPr lang="de-DE" sz="2400" dirty="0"/>
+              <a:t> </a:t>
+            </a:r>
+            <a:r>
+              <a:rPr lang="de-DE" sz="2400" dirty="0" err="1"/>
+              <a:t>official</a:t>
+            </a:r>
+            <a:r>
+              <a:rPr lang="de-DE" sz="2400" dirty="0"/>
+              <a:t> </a:t>
+            </a:r>
+            <a:r>
+              <a:rPr lang="de-DE" sz="2400" dirty="0" err="1"/>
+              <a:t>paper</a:t>
+            </a:r>
+            <a:br>
+              <a:rPr lang="de-DE" sz="2400" dirty="0"/>
+            </a:br>
+            <a:r>
+              <a:rPr lang="de-DE" sz="2400" dirty="0"/>
+              <a:t>- Use </a:t>
+            </a:r>
+            <a:r>
+              <a:rPr lang="de-DE" sz="2400" dirty="0" err="1"/>
+              <a:t>the</a:t>
+            </a:r>
+            <a:r>
+              <a:rPr lang="de-DE" sz="2400" dirty="0"/>
+              <a:t> </a:t>
+            </a:r>
+            <a:r>
+              <a:rPr lang="de-DE" sz="2400" dirty="0" err="1"/>
+              <a:t>actor-critic</a:t>
+            </a:r>
+            <a:r>
+              <a:rPr lang="de-DE" sz="2400" dirty="0"/>
+              <a:t> </a:t>
+            </a:r>
+            <a:r>
+              <a:rPr lang="de-DE" sz="2400" dirty="0" err="1"/>
+              <a:t>formulation</a:t>
+            </a:r>
+            <a:r>
+              <a:rPr lang="de-DE" sz="2400" dirty="0"/>
+              <a:t> </a:t>
+            </a:r>
+            <a:r>
+              <a:rPr lang="de-DE" sz="2400" dirty="0" err="1"/>
+              <a:t>with</a:t>
+            </a:r>
+            <a:r>
+              <a:rPr lang="de-DE" sz="2400" dirty="0"/>
+              <a:t> </a:t>
+            </a:r>
+            <a:r>
+              <a:rPr lang="de-DE" sz="2400" dirty="0" err="1"/>
+              <a:t>alternating</a:t>
+            </a:r>
+            <a:r>
+              <a:rPr lang="de-DE" sz="2400" dirty="0"/>
+              <a:t> </a:t>
+            </a:r>
+            <a:r>
+              <a:rPr lang="de-DE" sz="2400" dirty="0" err="1"/>
+              <a:t>policy</a:t>
+            </a:r>
+            <a:r>
+              <a:rPr lang="de-DE" sz="2400" dirty="0"/>
+              <a:t> and </a:t>
+            </a:r>
+            <a:r>
+              <a:rPr lang="de-DE" sz="2400" dirty="0" err="1"/>
+              <a:t>value</a:t>
+            </a:r>
+            <a:r>
+              <a:rPr lang="de-DE" sz="2400" dirty="0"/>
+              <a:t> </a:t>
+            </a:r>
+            <a:r>
+              <a:rPr lang="de-DE" sz="2400" dirty="0" err="1"/>
+              <a:t>updates</a:t>
+            </a:r>
+            <a:br>
+              <a:rPr lang="de-DE" sz="2400" dirty="0"/>
+            </a:br>
+            <a:r>
+              <a:rPr lang="de-DE" sz="2400" dirty="0"/>
+              <a:t>- </a:t>
+            </a:r>
+            <a:r>
+              <a:rPr lang="de-DE" sz="2400" dirty="0" err="1"/>
+              <a:t>Verify</a:t>
+            </a:r>
+            <a:r>
+              <a:rPr lang="de-DE" sz="2400" dirty="0"/>
+              <a:t> </a:t>
+            </a:r>
+            <a:r>
+              <a:rPr lang="de-DE" sz="2400" dirty="0" err="1"/>
+              <a:t>the</a:t>
+            </a:r>
+            <a:r>
+              <a:rPr lang="de-DE" sz="2400" dirty="0"/>
+              <a:t> </a:t>
+            </a:r>
+            <a:r>
+              <a:rPr lang="de-DE" sz="2400" dirty="0" err="1"/>
+              <a:t>implementation</a:t>
+            </a:r>
+            <a:r>
+              <a:rPr lang="de-DE" sz="2400" dirty="0"/>
+              <a:t> on </a:t>
+            </a:r>
+            <a:r>
+              <a:rPr lang="de-DE" sz="2400" dirty="0" err="1"/>
+              <a:t>standard</a:t>
+            </a:r>
+            <a:r>
+              <a:rPr lang="de-DE" sz="2400" dirty="0"/>
+              <a:t> </a:t>
+            </a:r>
+            <a:r>
+              <a:rPr lang="de-DE" sz="2400" dirty="0" err="1"/>
+              <a:t>continuous-control</a:t>
+            </a:r>
+            <a:r>
+              <a:rPr lang="de-DE" sz="2400" dirty="0"/>
+              <a:t> </a:t>
+            </a:r>
+            <a:r>
+              <a:rPr lang="de-DE" sz="2400" dirty="0" err="1"/>
+              <a:t>benchmarks</a:t>
+            </a:r>
+            <a:r>
+              <a:rPr lang="de-DE" sz="2400" dirty="0"/>
+              <a:t> (e.g. </a:t>
+            </a:r>
+            <a:r>
+              <a:rPr lang="de-DE" sz="2400" dirty="0" err="1"/>
+              <a:t>cartpole</a:t>
+            </a:r>
+            <a:r>
+              <a:rPr lang="de-DE" sz="2400" dirty="0"/>
+              <a:t> </a:t>
+            </a:r>
+            <a:r>
+              <a:rPr lang="de-DE" sz="2400" dirty="0" err="1"/>
               <a:t>swingup</a:t>
             </a:r>
-            <a:endParaRPr lang="en-US" sz="1600" i="1" dirty="0">
+            <a:r>
+              <a:rPr lang="de-DE" sz="2400" dirty="0"/>
+              <a:t>)</a:t>
+            </a:r>
+            <a:endParaRPr lang="en-US" sz="2400" b="1" dirty="0">
               <a:solidFill>
                 <a:schemeClr val="dk1"/>
               </a:solidFill>
             </a:endParaRPr>
           </a:p>
           <a:p>
-            <a:pPr marL="285750" lvl="0" indent="-285750" algn="l" rtl="0">
-              <a:spcBef>
-                <a:spcPts val="0"/>
-              </a:spcBef>
-              <a:spcAft>
-                <a:spcPts val="0"/>
-              </a:spcAft>
+            <a:pPr marL="457200" lvl="5" indent="-457200">
               <a:buFont typeface="Arial" panose="020B0604020202020204" pitchFamily="34" charset="0"/>
               <a:buChar char="•"/>
             </a:pPr>
-            <a:r>
-              <a:rPr lang="en-US" sz="1600" dirty="0">
+            <a:endParaRPr lang="en-US" sz="2400" b="1" dirty="0">
+              <a:solidFill>
+                <a:schemeClr val="dk1"/>
+              </a:solidFill>
+            </a:endParaRPr>
+          </a:p>
+          <a:p>
+            <a:pPr marL="457200" lvl="0" indent="-457200">
+              <a:buFont typeface="+mj-lt"/>
+              <a:buAutoNum type="arabicPeriod"/>
+            </a:pPr>
+            <a:r>
+              <a:rPr lang="en-US" sz="2400" b="1" dirty="0">
                 <a:solidFill>
                   <a:schemeClr val="dk1"/>
                 </a:solidFill>
               </a:rPr>
-              <a:t>Implement incrementally more difficult environments (first cartpole with ball, then with joint, then standing agent, then walking agent, then with ball)</a:t>
-            </a:r>
+              <a:t>Curriculum Learning</a:t>
+            </a:r>
+            <a:br>
+              <a:rPr lang="en-US" sz="2400" b="1" dirty="0">
+                <a:solidFill>
+                  <a:schemeClr val="dk1"/>
+                </a:solidFill>
+              </a:rPr>
+            </a:br>
+            <a:r>
+              <a:rPr lang="en-US" sz="2400" b="1" dirty="0">
+                <a:solidFill>
+                  <a:schemeClr val="dk1"/>
+                </a:solidFill>
+              </a:rPr>
+              <a:t>- </a:t>
+            </a:r>
+            <a:r>
+              <a:rPr lang="en-US" sz="2400" dirty="0">
+                <a:solidFill>
+                  <a:schemeClr val="dk1"/>
+                </a:solidFill>
+              </a:rPr>
+              <a:t>Train agent on </a:t>
+            </a:r>
+            <a:r>
+              <a:rPr lang="en-US" sz="2400" dirty="0" err="1">
+                <a:solidFill>
+                  <a:schemeClr val="dk1"/>
+                </a:solidFill>
+              </a:rPr>
+              <a:t>dm_control</a:t>
+            </a:r>
+            <a:r>
+              <a:rPr lang="en-US" sz="2400" dirty="0">
+                <a:solidFill>
+                  <a:schemeClr val="dk1"/>
+                </a:solidFill>
+              </a:rPr>
+              <a:t> native tasks to validate correctness</a:t>
+            </a:r>
+            <a:br>
+              <a:rPr lang="en-US" sz="2400" dirty="0">
+                <a:solidFill>
+                  <a:schemeClr val="dk1"/>
+                </a:solidFill>
+              </a:rPr>
+            </a:br>
+            <a:r>
+              <a:rPr lang="en-US" sz="2400" dirty="0">
+                <a:solidFill>
+                  <a:schemeClr val="dk1"/>
+                </a:solidFill>
+              </a:rPr>
+              <a:t>- Increase task complexity incrementally </a:t>
+            </a:r>
+            <a:r>
+              <a:rPr lang="de-DE" sz="2400" dirty="0" err="1"/>
+              <a:t>by</a:t>
+            </a:r>
+            <a:r>
+              <a:rPr lang="de-DE" sz="2400" dirty="0"/>
+              <a:t> </a:t>
+            </a:r>
+            <a:r>
+              <a:rPr lang="de-DE" sz="2400" dirty="0" err="1"/>
+              <a:t>introducing</a:t>
+            </a:r>
+            <a:r>
+              <a:rPr lang="de-DE" sz="2400" dirty="0"/>
+              <a:t> </a:t>
+            </a:r>
+            <a:r>
+              <a:rPr lang="de-DE" sz="2400" dirty="0" err="1"/>
+              <a:t>custom</a:t>
+            </a:r>
+            <a:r>
+              <a:rPr lang="de-DE" sz="2400" dirty="0"/>
+              <a:t> </a:t>
+            </a:r>
+            <a:r>
+              <a:rPr lang="de-DE" sz="2400" dirty="0" err="1"/>
+              <a:t>environments</a:t>
+            </a:r>
+            <a:r>
+              <a:rPr lang="de-DE" sz="2400" dirty="0"/>
+              <a:t> </a:t>
+            </a:r>
+            <a:r>
+              <a:rPr lang="de-DE" sz="2400" dirty="0" err="1"/>
+              <a:t>that</a:t>
+            </a:r>
+            <a:r>
+              <a:rPr lang="de-DE" sz="2400" dirty="0"/>
+              <a:t> </a:t>
+            </a:r>
+            <a:r>
+              <a:rPr lang="de-DE" sz="2400" dirty="0" err="1"/>
+              <a:t>require</a:t>
+            </a:r>
+            <a:r>
+              <a:rPr lang="de-DE" sz="2400" dirty="0"/>
+              <a:t> </a:t>
+            </a:r>
+            <a:r>
+              <a:rPr lang="de-DE" sz="2400" dirty="0" err="1"/>
+              <a:t>more</a:t>
+            </a:r>
+            <a:r>
+              <a:rPr lang="de-DE" sz="2400" dirty="0"/>
+              <a:t> sophisticated </a:t>
+            </a:r>
+            <a:r>
+              <a:rPr lang="de-DE" sz="2400" dirty="0" err="1"/>
+              <a:t>control</a:t>
+            </a:r>
+            <a:br>
+              <a:rPr lang="de-DE" sz="2400" dirty="0"/>
+            </a:br>
+            <a:r>
+              <a:rPr lang="de-DE" sz="2400" dirty="0"/>
+              <a:t>- </a:t>
+            </a:r>
+            <a:r>
+              <a:rPr lang="de-DE" sz="2400" dirty="0" err="1"/>
+              <a:t>Verify</a:t>
+            </a:r>
+            <a:r>
+              <a:rPr lang="de-DE" sz="2400" dirty="0"/>
+              <a:t> </a:t>
+            </a:r>
+            <a:r>
+              <a:rPr lang="de-DE" sz="2400" dirty="0" err="1"/>
+              <a:t>if</a:t>
+            </a:r>
+            <a:r>
+              <a:rPr lang="de-DE" sz="2400" dirty="0"/>
+              <a:t> </a:t>
+            </a:r>
+            <a:r>
+              <a:rPr lang="de-DE" sz="2400" dirty="0" err="1"/>
+              <a:t>policy</a:t>
+            </a:r>
+            <a:r>
+              <a:rPr lang="de-DE" sz="2400" dirty="0"/>
+              <a:t> </a:t>
+            </a:r>
+            <a:r>
+              <a:rPr lang="de-DE" sz="2400" dirty="0" err="1"/>
+              <a:t>can</a:t>
+            </a:r>
+            <a:r>
+              <a:rPr lang="de-DE" sz="2400" dirty="0"/>
+              <a:t> </a:t>
+            </a:r>
+            <a:r>
+              <a:rPr lang="de-DE" sz="2400" dirty="0" err="1"/>
+              <a:t>learn</a:t>
+            </a:r>
+            <a:r>
+              <a:rPr lang="de-DE" sz="2400" dirty="0"/>
+              <a:t> intermediate </a:t>
+            </a:r>
+            <a:r>
+              <a:rPr lang="de-DE" sz="2400" dirty="0" err="1"/>
+              <a:t>tasks</a:t>
+            </a:r>
+            <a:r>
+              <a:rPr lang="de-DE" sz="2400" dirty="0"/>
+              <a:t>, </a:t>
+            </a:r>
+            <a:r>
+              <a:rPr lang="de-DE" sz="2400" dirty="0" err="1"/>
+              <a:t>by</a:t>
+            </a:r>
+            <a:r>
+              <a:rPr lang="de-DE" sz="2400" dirty="0"/>
+              <a:t> </a:t>
+            </a:r>
+            <a:r>
+              <a:rPr lang="de-DE" sz="2400" dirty="0" err="1"/>
+              <a:t>progressing</a:t>
+            </a:r>
+            <a:r>
+              <a:rPr lang="de-DE" sz="2400" dirty="0"/>
+              <a:t> </a:t>
+            </a:r>
+            <a:r>
+              <a:rPr lang="de-DE" sz="2400" dirty="0" err="1"/>
+              <a:t>from</a:t>
+            </a:r>
+            <a:r>
+              <a:rPr lang="de-DE" sz="2400" dirty="0"/>
+              <a:t> </a:t>
+            </a:r>
+            <a:r>
+              <a:rPr lang="de-DE" sz="2400" dirty="0" err="1"/>
+              <a:t>simplified</a:t>
+            </a:r>
+            <a:r>
+              <a:rPr lang="de-DE" sz="2400" dirty="0"/>
+              <a:t> </a:t>
+            </a:r>
+            <a:r>
+              <a:rPr lang="de-DE" sz="2400" dirty="0" err="1"/>
+              <a:t>soccer-related</a:t>
+            </a:r>
+            <a:r>
+              <a:rPr lang="de-DE" sz="2400" dirty="0"/>
+              <a:t> </a:t>
+            </a:r>
+            <a:r>
+              <a:rPr lang="de-DE" sz="2400" dirty="0" err="1"/>
+              <a:t>environments</a:t>
+            </a:r>
+            <a:r>
+              <a:rPr lang="de-DE" sz="2400" dirty="0"/>
+              <a:t> (e.g. </a:t>
+            </a:r>
+            <a:r>
+              <a:rPr lang="de-DE" sz="2400" dirty="0" err="1"/>
+              <a:t>one</a:t>
+            </a:r>
+            <a:r>
+              <a:rPr lang="de-DE" sz="2400" dirty="0"/>
+              <a:t>-joint stick man) </a:t>
+            </a:r>
+            <a:r>
+              <a:rPr lang="de-DE" sz="2400" dirty="0" err="1"/>
+              <a:t>to</a:t>
+            </a:r>
+            <a:r>
+              <a:rPr lang="de-DE" sz="2400" dirty="0"/>
+              <a:t> </a:t>
+            </a:r>
+            <a:r>
+              <a:rPr lang="de-DE" sz="2400" dirty="0" err="1"/>
+              <a:t>the</a:t>
+            </a:r>
+            <a:r>
+              <a:rPr lang="de-DE" sz="2400" dirty="0"/>
+              <a:t> </a:t>
+            </a:r>
+            <a:r>
+              <a:rPr lang="de-DE" sz="2400" dirty="0" err="1"/>
+              <a:t>full</a:t>
+            </a:r>
+            <a:r>
+              <a:rPr lang="de-DE" sz="2400" dirty="0"/>
+              <a:t> humanoid </a:t>
+            </a:r>
+            <a:r>
+              <a:rPr lang="de-DE" sz="2400" dirty="0" err="1"/>
+              <a:t>soccer</a:t>
+            </a:r>
+            <a:r>
+              <a:rPr lang="de-DE" sz="2400" dirty="0"/>
+              <a:t> </a:t>
+            </a:r>
+            <a:r>
+              <a:rPr lang="de-DE" sz="2400" dirty="0" err="1"/>
+              <a:t>task</a:t>
+            </a:r>
+            <a:br>
+              <a:rPr lang="en-US" sz="2400" b="1" dirty="0">
+                <a:solidFill>
+                  <a:schemeClr val="dk1"/>
+                </a:solidFill>
+              </a:rPr>
+            </a:br>
+            <a:endParaRPr lang="en-US" sz="2400" b="1" dirty="0">
+              <a:solidFill>
+                <a:schemeClr val="dk1"/>
+              </a:solidFill>
+            </a:endParaRPr>
+          </a:p>
+          <a:p>
+            <a:pPr marL="457200" lvl="0" indent="-457200">
+              <a:buFont typeface="+mj-lt"/>
+              <a:buAutoNum type="arabicPeriod"/>
+            </a:pPr>
+            <a:r>
+              <a:rPr lang="en-US" sz="2400" b="1" dirty="0">
+                <a:solidFill>
+                  <a:schemeClr val="dk1"/>
+                </a:solidFill>
+              </a:rPr>
+              <a:t>Robot Soccer Training</a:t>
+            </a:r>
+            <a:br>
+              <a:rPr lang="en-US" sz="2400" b="1" dirty="0">
+                <a:solidFill>
+                  <a:schemeClr val="dk1"/>
+                </a:solidFill>
+              </a:rPr>
+            </a:br>
+            <a:r>
+              <a:rPr lang="en-US" sz="2400" b="1" dirty="0">
+                <a:solidFill>
+                  <a:schemeClr val="dk1"/>
+                </a:solidFill>
+              </a:rPr>
+              <a:t>- </a:t>
+            </a:r>
+            <a:r>
+              <a:rPr lang="de-DE" sz="2400" dirty="0"/>
+              <a:t>Train </a:t>
+            </a:r>
+            <a:r>
+              <a:rPr lang="de-DE" sz="2400" dirty="0" err="1"/>
+              <a:t>the</a:t>
+            </a:r>
+            <a:r>
+              <a:rPr lang="de-DE" sz="2400" dirty="0"/>
+              <a:t> final </a:t>
+            </a:r>
+            <a:r>
+              <a:rPr lang="de-DE" sz="2400" dirty="0" err="1"/>
+              <a:t>policy</a:t>
+            </a:r>
+            <a:r>
+              <a:rPr lang="de-DE" sz="2400" dirty="0"/>
+              <a:t> in </a:t>
+            </a:r>
+            <a:r>
+              <a:rPr lang="de-DE" sz="2400" dirty="0" err="1"/>
+              <a:t>the</a:t>
+            </a:r>
+            <a:r>
+              <a:rPr lang="de-DE" sz="2400" dirty="0"/>
+              <a:t> DeepMind Control Soccer </a:t>
+            </a:r>
+            <a:r>
+              <a:rPr lang="de-DE" sz="2400" dirty="0" err="1"/>
+              <a:t>environment</a:t>
+            </a:r>
+            <a:br>
+              <a:rPr lang="de-DE" sz="2400" dirty="0"/>
+            </a:br>
+            <a:r>
+              <a:rPr lang="de-DE" sz="2400" dirty="0"/>
+              <a:t>- </a:t>
+            </a:r>
+            <a:r>
+              <a:rPr lang="de-DE" sz="2400" dirty="0" err="1"/>
+              <a:t>Evaluate</a:t>
+            </a:r>
+            <a:r>
+              <a:rPr lang="de-DE" sz="2400" dirty="0"/>
+              <a:t> </a:t>
+            </a:r>
+            <a:r>
+              <a:rPr lang="de-DE" sz="2400" dirty="0" err="1"/>
+              <a:t>learning</a:t>
+            </a:r>
+            <a:r>
+              <a:rPr lang="de-DE" sz="2400" dirty="0"/>
+              <a:t> </a:t>
+            </a:r>
+            <a:r>
+              <a:rPr lang="de-DE" sz="2400" dirty="0" err="1"/>
+              <a:t>through</a:t>
+            </a:r>
+            <a:r>
+              <a:rPr lang="de-DE" sz="2400" dirty="0"/>
+              <a:t> qualitative </a:t>
+            </a:r>
+            <a:r>
+              <a:rPr lang="de-DE" sz="2400" dirty="0" err="1"/>
+              <a:t>behavior</a:t>
+            </a:r>
+            <a:r>
+              <a:rPr lang="de-DE" sz="2400" dirty="0"/>
+              <a:t> (</a:t>
+            </a:r>
+            <a:r>
+              <a:rPr lang="de-DE" sz="2400" dirty="0" err="1"/>
+              <a:t>video</a:t>
+            </a:r>
+            <a:r>
+              <a:rPr lang="de-DE" sz="2400" dirty="0"/>
+              <a:t> </a:t>
+            </a:r>
+            <a:r>
+              <a:rPr lang="de-DE" sz="2400" dirty="0" err="1"/>
+              <a:t>frames</a:t>
+            </a:r>
+            <a:r>
+              <a:rPr lang="de-DE" sz="2400" dirty="0"/>
+              <a:t>) and quantitative </a:t>
+            </a:r>
+            <a:r>
+              <a:rPr lang="de-DE" sz="2400" dirty="0" err="1"/>
+              <a:t>metrics</a:t>
+            </a:r>
+            <a:r>
+              <a:rPr lang="de-DE" sz="2400" dirty="0"/>
+              <a:t> (</a:t>
+            </a:r>
+            <a:r>
+              <a:rPr lang="de-DE" sz="2400" dirty="0" err="1"/>
+              <a:t>episode</a:t>
+            </a:r>
+            <a:r>
+              <a:rPr lang="de-DE" sz="2400" dirty="0"/>
+              <a:t> </a:t>
+            </a:r>
+            <a:r>
+              <a:rPr lang="de-DE" sz="2400" dirty="0" err="1"/>
+              <a:t>returns</a:t>
+            </a:r>
+            <a:r>
+              <a:rPr lang="de-DE" sz="2400" dirty="0"/>
+              <a:t>)</a:t>
+            </a:r>
+            <a:br>
+              <a:rPr lang="de-DE" sz="2400" dirty="0"/>
+            </a:br>
+            <a:r>
+              <a:rPr lang="de-DE" sz="2400" dirty="0"/>
+              <a:t>- Analyze </a:t>
+            </a:r>
+            <a:r>
+              <a:rPr lang="de-DE" sz="2400" dirty="0" err="1"/>
+              <a:t>whether</a:t>
+            </a:r>
+            <a:r>
+              <a:rPr lang="de-DE" sz="2400" dirty="0"/>
+              <a:t> </a:t>
+            </a:r>
+            <a:r>
+              <a:rPr lang="de-DE" sz="2400" dirty="0" err="1"/>
+              <a:t>the</a:t>
+            </a:r>
+            <a:r>
+              <a:rPr lang="de-DE" sz="2400" dirty="0"/>
+              <a:t> </a:t>
+            </a:r>
+            <a:r>
+              <a:rPr lang="de-DE" sz="2400" dirty="0" err="1"/>
+              <a:t>agent</a:t>
+            </a:r>
+            <a:r>
+              <a:rPr lang="de-DE" sz="2400" dirty="0"/>
+              <a:t> </a:t>
+            </a:r>
+            <a:r>
+              <a:rPr lang="de-DE" sz="2400" dirty="0" err="1"/>
+              <a:t>acquires</a:t>
+            </a:r>
+            <a:r>
+              <a:rPr lang="de-DE" sz="2400" dirty="0"/>
+              <a:t> </a:t>
+            </a:r>
+            <a:r>
+              <a:rPr lang="de-DE" sz="2400" dirty="0" err="1"/>
+              <a:t>the</a:t>
+            </a:r>
+            <a:r>
+              <a:rPr lang="de-DE" sz="2400" dirty="0"/>
+              <a:t> </a:t>
+            </a:r>
+            <a:r>
+              <a:rPr lang="de-DE" sz="2400" dirty="0" err="1"/>
+              <a:t>necessary</a:t>
+            </a:r>
+            <a:r>
+              <a:rPr lang="de-DE" sz="2400" dirty="0"/>
+              <a:t> </a:t>
+            </a:r>
+            <a:r>
+              <a:rPr lang="de-DE" sz="2400" dirty="0" err="1"/>
+              <a:t>skills</a:t>
+            </a:r>
+            <a:r>
+              <a:rPr lang="de-DE" sz="2400" dirty="0"/>
+              <a:t> </a:t>
+            </a:r>
+            <a:r>
+              <a:rPr lang="de-DE" sz="2400" dirty="0" err="1"/>
+              <a:t>to</a:t>
+            </a:r>
+            <a:r>
+              <a:rPr lang="de-DE" sz="2400" dirty="0"/>
+              <a:t> </a:t>
+            </a:r>
+            <a:r>
+              <a:rPr lang="de-DE" sz="2400" dirty="0" err="1"/>
+              <a:t>consistently</a:t>
+            </a:r>
+            <a:r>
+              <a:rPr lang="de-DE" sz="2400" dirty="0"/>
+              <a:t> </a:t>
+            </a:r>
+            <a:r>
+              <a:rPr lang="de-DE" sz="2400" dirty="0" err="1"/>
+              <a:t>approach</a:t>
+            </a:r>
+            <a:r>
+              <a:rPr lang="de-DE" sz="2400" dirty="0"/>
+              <a:t>, </a:t>
+            </a:r>
+            <a:r>
+              <a:rPr lang="de-DE" sz="2400" dirty="0" err="1"/>
+              <a:t>control</a:t>
+            </a:r>
+            <a:r>
+              <a:rPr lang="de-DE" sz="2400" dirty="0"/>
+              <a:t>, and score </a:t>
+            </a:r>
+            <a:r>
+              <a:rPr lang="de-DE" sz="2400" dirty="0" err="1"/>
+              <a:t>with</a:t>
+            </a:r>
+            <a:r>
+              <a:rPr lang="de-DE" sz="2400" dirty="0"/>
+              <a:t> </a:t>
+            </a:r>
+            <a:r>
+              <a:rPr lang="de-DE" sz="2400" dirty="0" err="1"/>
+              <a:t>the</a:t>
+            </a:r>
+            <a:r>
+              <a:rPr lang="de-DE" sz="2400" dirty="0"/>
+              <a:t> ball</a:t>
+            </a:r>
+            <a:endParaRPr lang="en-US" sz="2400" b="1" dirty="0">
+              <a:solidFill>
+                <a:schemeClr val="dk1"/>
+              </a:solidFill>
+            </a:endParaRPr>
+          </a:p>
+          <a:p>
+            <a:pPr marL="457200" lvl="0" indent="-457200" algn="l" rtl="0">
+              <a:spcBef>
+                <a:spcPts val="0"/>
+              </a:spcBef>
+              <a:spcAft>
+                <a:spcPts val="0"/>
+              </a:spcAft>
+              <a:buFont typeface="+mj-lt"/>
+              <a:buAutoNum type="arabicPeriod"/>
+            </a:pPr>
+            <a:endParaRPr lang="en-US" sz="2400" b="1" dirty="0">
+              <a:solidFill>
+                <a:schemeClr val="dk1"/>
+              </a:solidFill>
+            </a:endParaRPr>
           </a:p>
         </p:txBody>
       </p:sp>
@@ -3989,21 +5017,26 @@
           </a:ln>
         </p:spPr>
         <p:txBody>
-          <a:bodyPr spcFirstLastPara="1" wrap="square" lIns="81850" tIns="81850" rIns="81850" bIns="81850" anchor="ctr" anchorCtr="0">
+          <a:bodyPr spcFirstLastPara="1" wrap="square" lIns="81850" tIns="81850" rIns="81850" bIns="81850" anchor="t" anchorCtr="0">
             <a:noAutofit/>
           </a:bodyPr>
           <a:lstStyle/>
           <a:p>
-            <a:pPr marL="0" lvl="0" indent="0" algn="l" rtl="0">
-              <a:spcBef>
-                <a:spcPts val="0"/>
-              </a:spcBef>
-              <a:spcAft>
-                <a:spcPts val="0"/>
-              </a:spcAft>
-              <a:buNone/>
+            <a:pPr marL="285750" lvl="0" indent="-285750" algn="l" rtl="0">
+              <a:spcBef>
+                <a:spcPts val="0"/>
+              </a:spcBef>
+              <a:spcAft>
+                <a:spcPts val="0"/>
+              </a:spcAft>
+              <a:buFont typeface="Arial" panose="020B0604020202020204" pitchFamily="34" charset="0"/>
+              <a:buChar char="•"/>
             </a:pPr>
-            <a:endParaRPr/>
+            <a:r>
+              <a:rPr lang="en-US" sz="2400" dirty="0"/>
+              <a:t>Video Frames of main evolution steps</a:t>
+            </a:r>
+            <a:endParaRPr sz="2400" dirty="0"/>
           </a:p>
         </p:txBody>
       </p:sp>
@@ -4042,14 +5075,14 @@
               <a:buNone/>
             </a:pPr>
             <a:r>
-              <a:rPr lang="en-US" sz="5400" b="1">
+              <a:rPr lang="en-US" sz="5400" b="1" dirty="0">
                 <a:solidFill>
                   <a:srgbClr val="344A9A"/>
                 </a:solidFill>
               </a:rPr>
               <a:t>Qualitative Results</a:t>
             </a:r>
-            <a:endParaRPr sz="5400" b="1">
+            <a:endParaRPr sz="5400" b="1" dirty="0">
               <a:solidFill>
                 <a:srgbClr val="344A9A"/>
               </a:solidFill>
@@ -4085,21 +5118,30 @@
           </a:ln>
         </p:spPr>
         <p:txBody>
-          <a:bodyPr spcFirstLastPara="1" wrap="square" lIns="81850" tIns="81850" rIns="81850" bIns="81850" anchor="ctr" anchorCtr="0">
+          <a:bodyPr spcFirstLastPara="1" wrap="square" lIns="81850" tIns="81850" rIns="81850" bIns="81850" anchor="t" anchorCtr="0">
             <a:noAutofit/>
           </a:bodyPr>
           <a:lstStyle/>
           <a:p>
-            <a:pPr marL="0" lvl="0" indent="0" algn="l" rtl="0">
-              <a:spcBef>
-                <a:spcPts val="0"/>
-              </a:spcBef>
-              <a:spcAft>
-                <a:spcPts val="0"/>
-              </a:spcAft>
-              <a:buNone/>
+            <a:pPr marL="285750" lvl="0" indent="-285750" algn="l" rtl="0">
+              <a:spcBef>
+                <a:spcPts val="0"/>
+              </a:spcBef>
+              <a:spcAft>
+                <a:spcPts val="0"/>
+              </a:spcAft>
+              <a:buFont typeface="Arial" panose="020B0604020202020204" pitchFamily="34" charset="0"/>
+              <a:buChar char="•"/>
             </a:pPr>
-            <a:endParaRPr/>
+            <a:r>
+              <a:rPr lang="en-US" sz="2400" dirty="0" err="1"/>
+              <a:t>Tensorboard</a:t>
+            </a:r>
+            <a:r>
+              <a:rPr lang="en-US" sz="2400" dirty="0"/>
+              <a:t> logs (prettified)</a:t>
+            </a:r>
+            <a:endParaRPr sz="2400" dirty="0"/>
           </a:p>
         </p:txBody>
       </p:sp>
@@ -4138,14 +5180,14 @@
               <a:buNone/>
             </a:pPr>
             <a:r>
-              <a:rPr lang="en-US" sz="5400" b="1">
+              <a:rPr lang="en-US" sz="5400" b="1" dirty="0">
                 <a:solidFill>
                   <a:srgbClr val="344A9A"/>
                 </a:solidFill>
               </a:rPr>
               <a:t>Quantitative Results</a:t>
             </a:r>
-            <a:endParaRPr sz="5400" b="1">
+            <a:endParaRPr sz="5400" b="1" dirty="0">
               <a:solidFill>
                 <a:srgbClr val="344A9A"/>
               </a:solidFill>
@@ -4271,6 +5313,36 @@
           </a:p>
         </p:txBody>
       </p:sp>
+      <p:pic>
+        <p:nvPicPr>
+          <p:cNvPr id="3" name="Picture 2">
+            <a:extLst>
+              <a:ext uri="{FF2B5EF4-FFF2-40B4-BE49-F238E27FC236}">
+                <a16:creationId xmlns:a16="http://schemas.microsoft.com/office/drawing/2014/main" id="{CFC16333-634B-0121-1541-C9322BEB6FA7}"/>
+              </a:ext>
+            </a:extLst>
+          </p:cNvPr>
+          <p:cNvPicPr>
+            <a:picLocks noChangeAspect="1"/>
+          </p:cNvPicPr>
+          <p:nvPr/>
+        </p:nvPicPr>
+        <p:blipFill>
+          <a:blip r:embed="rId5"/>
+          <a:stretch>
+            <a:fillRect/>
+          </a:stretch>
+        </p:blipFill>
+        <p:spPr>
+          <a:xfrm>
+            <a:off x="21485820" y="8436540"/>
+            <a:ext cx="7343775" cy="5467350"/>
+          </a:xfrm>
+          <a:prstGeom prst="rect">
+            <a:avLst/>
+          </a:prstGeom>
+        </p:spPr>
+      </p:pic>
     </p:spTree>
   </p:cSld>
   <p:clrMapOvr>

</xml_diff>